<commit_message>
Relabel 'published' -> 'July baseline/objective' in g8 and results-table slide; both state nothing is published yet
Co-Authored-By: Claude Opus 5 <noreply@anthropic.com>
</commit_message>
<xml_diff>
--- a/docs/vogiatzis_results_table_2026-08.pptx
+++ b/docs/vogiatzis_results_table_2026-08.pptx
@@ -502,7 +502,7 @@
           <a:lstStyle/>
           <a:p>
             <a:r>
-              <a:t>Every number is out-of-fold under leave-extractants-out CV (5x3), ensembled over 16-32 seeds. Best at absolute log D (trees, 0.508) is not best at separations - that is why the combination exists and why the loss was re-aimed at the pairs. The contrast-weight change trades overall for pairs on the simplicial arm (0.359/0.239 -&gt; 0.341/0.243); on the distance arm it gives 0.343/0.266. The 0.313 pair-fitted combination is exploratory: no clean held-out partition remains. Ceiling from 203 repeated (composition, adjacent-pair) cases: reproducibility 0.153 vs spread 0.224.</a:t>
+              <a:t>Every number is out-of-fold under leave-extractants-out CV (5x3), ensembled over 16-32 seeds. 'July baseline' refers to the internal July 22 report (docs/README_2026-07-22.md), the frozen pre-registered result of the topology campaign - not a publication. Best at absolute log D (trees, 0.508) is not best at separations - that is why the combination exists and why the loss was re-aimed at the pairs. The contrast-weight change trades overall for pairs on the simplicial arm (0.359/0.239 -&gt; 0.341/0.243); on the distance arm it gives 0.343/0.266. The 0.313 pair-fitted combination is exploratory: no clean held-out partition remains. Ceiling from 203 repeated (composition, adjacent-pair) cases: reproducibility 0.153 vs spread 0.224.</a:t>
             </a:r>
           </a:p>
         </p:txBody>
@@ -3882,7 +3882,7 @@
                             <a:srgbClr val="101214"/>
                           </a:solidFill>
                         </a:rPr>
-                        <a:t>3D simplicial network, published objective</a:t>
+                        <a:t>3D simplicial network, July objective</a:t>
                       </a:r>
                     </a:p>
                   </a:txBody>
@@ -4018,7 +4018,7 @@
                             <a:srgbClr val="101214"/>
                           </a:solidFill>
                         </a:rPr>
-                        <a:t>Published 3-model combination</a:t>
+                        <a:t>July 3-model combination (baseline)</a:t>
                       </a:r>
                     </a:p>
                   </a:txBody>
@@ -4222,7 +4222,7 @@
         <p:spPr>
           <a:xfrm>
             <a:off x="822960" y="5897880"/>
-            <a:ext cx="10515600" cy="640080"/>
+            <a:ext cx="10515600" cy="731520"/>
           </a:xfrm>
           <a:prstGeom prst="rect">
             <a:avLst/>
@@ -4241,7 +4241,7 @@
                   <a:srgbClr val="52514E"/>
                 </a:solidFill>
               </a:rPr>
-              <a:t>Trees and 3D arms include this campaign's loss changes; 'published objective' = contrast weight 2. The pair-fitted combination optimises pairs only, so it has no overall score. Ceiling: separations reproduce to ±0.153 on a spread of 0.224 → 1 − (0.153/0.224)² ≈ 0.53.</a:t>
+              <a:t>'July objective' / 'July baseline' = the objective and 3-model stack frozen in the July 2026 internal report (contrast weight 2), before this campaign's loss changes — nothing is published yet. The pair-fitted combination optimises pairs only, so it has no overall score. Ceiling: separations reproduce to ±0.153 on a spread of 0.224 → 1 − (0.153/0.224)² ≈ 0.53.</a:t>
             </a:r>
           </a:p>
         </p:txBody>

</xml_diff>

<commit_message>
Results-table slide: combinations stated by exact membership and fitting criterion, no relative naming
Co-Authored-By: Claude Opus 5 <noreply@anthropic.com>
</commit_message>
<xml_diff>
--- a/docs/vogiatzis_results_table_2026-08.pptx
+++ b/docs/vogiatzis_results_table_2026-08.pptx
@@ -502,7 +502,7 @@
           <a:lstStyle/>
           <a:p>
             <a:r>
-              <a:t>Every number is out-of-fold under leave-extractants-out CV (5x3), ensembled over 16-32 seeds. 'July baseline' refers to the internal July 22 report (docs/README_2026-07-22.md), the frozen pre-registered result of the topology campaign - not a publication. Best at absolute log D (trees, 0.508) is not best at separations - that is why the combination exists and why the loss was re-aimed at the pairs. The contrast-weight change trades overall for pairs on the simplicial arm (0.359/0.239 -&gt; 0.341/0.243); on the distance arm it gives 0.343/0.266. The 0.313 pair-fitted combination is exploratory: no clean held-out partition remains. Ceiling from 203 repeated (composition, adjacent-pair) cases: reproducibility 0.153 vs spread 0.224.</a:t>
+              <a:t>Every number is out-of-fold under leave-extractants-out CV (5x3), ensembled over 16-32 seeds. Combination members, exactly: (a) row-fitted: CatBoost q60_rsm03_deep + fingerprint FCNN + simplicial network at pair-contrast weight 2, mixing weights fitted by minimising row-level log D error (source: best_stack.csv; the frozen July 22 internal result). (b) pair-fitted: CatBoost q60_rsm03_deep + fingerprint FCNN + distance encoder at pair-contrast weight 4, mixing weights fitted on the 905 adjacent-pair separations directly (source: c17_stack_new.csv, stack_adj_r2 = 0.3132). The pair-fitted combination is exploratory: no clean held-out partition remains. Best at absolute log D (CatBoost, 0.508) is worst-complementing on pairs alone - that is why combinations exist and why fitting the mix on pairs beats fitting it on rows. Ceiling from 203 repeated (composition, adjacent-pair) cases: reproducibility 0.153 vs spread 0.224.</a:t>
             </a:r>
           </a:p>
         </p:txBody>
@@ -3516,7 +3516,7 @@
         </p:nvSpPr>
         <p:spPr>
           <a:xfrm>
-            <a:off x="548640" y="320040"/>
+            <a:off x="548640" y="274320"/>
             <a:ext cx="11064240" cy="640080"/>
           </a:xfrm>
           <a:prstGeom prst="rect">
@@ -3549,7 +3549,7 @@
         </p:nvSpPr>
         <p:spPr>
           <a:xfrm>
-            <a:off x="548640" y="914400"/>
+            <a:off x="548640" y="868680"/>
             <a:ext cx="11064240" cy="457200"/>
           </a:xfrm>
           <a:prstGeom prst="rect">
@@ -3583,8 +3583,8 @@
           <p:nvPr/>
         </p:nvGraphicFramePr>
         <p:xfrm>
-          <a:off x="822960" y="1600200"/>
-          <a:ext cx="10515600" cy="3950208"/>
+          <a:off x="822960" y="1481328"/>
+          <a:ext cx="10515600" cy="3931920"/>
         </p:xfrm>
         <a:graphic>
           <a:graphicData uri="http://schemas.openxmlformats.org/drawingml/2006/table">
@@ -3593,19 +3593,19 @@
                 <a:tableStyleId>{5C22544A-7EE6-4342-B048-85BDC9FD1C3A}</a:tableStyleId>
               </a:tblPr>
               <a:tblGrid>
-                <a:gridCol w="5760720"/>
-                <a:gridCol w="2377440"/>
-                <a:gridCol w="2377440"/>
+                <a:gridCol w="6858000"/>
+                <a:gridCol w="1828800"/>
+                <a:gridCol w="1828800"/>
               </a:tblGrid>
-              <a:tr h="438912">
+              <a:tr h="384048">
                 <a:tc>
                   <a:txBody>
-                    <a:bodyPr/>
+                    <a:bodyPr wrap="square"/>
                     <a:lstStyle/>
                     <a:p>
                       <a:pPr algn="l"/>
                       <a:r>
-                        <a:rPr sz="1500" b="1">
+                        <a:rPr sz="1350" b="1">
                           <a:solidFill>
                             <a:srgbClr val="1A2E4A"/>
                           </a:solidFill>
@@ -3614,7 +3614,7 @@
                       </a:r>
                     </a:p>
                   </a:txBody>
-                  <a:tcPr marL="109728" marR="73152" marT="27432" marB="27432">
+                  <a:tcPr marL="91440" marR="54864" marT="18288" marB="18288">
                     <a:solidFill>
                       <a:srgbClr val="E3E5E8"/>
                     </a:solidFill>
@@ -3622,12 +3622,12 @@
                 </a:tc>
                 <a:tc>
                   <a:txBody>
-                    <a:bodyPr/>
+                    <a:bodyPr wrap="square"/>
                     <a:lstStyle/>
                     <a:p>
                       <a:pPr algn="ctr"/>
                       <a:r>
-                        <a:rPr sz="1500" b="1">
+                        <a:rPr sz="1350" b="1">
                           <a:solidFill>
                             <a:srgbClr val="1A2E4A"/>
                           </a:solidFill>
@@ -3636,7 +3636,7 @@
                       </a:r>
                     </a:p>
                   </a:txBody>
-                  <a:tcPr marL="109728" marR="73152" marT="27432" marB="27432">
+                  <a:tcPr marL="91440" marR="54864" marT="18288" marB="18288">
                     <a:solidFill>
                       <a:srgbClr val="E3E5E8"/>
                     </a:solidFill>
@@ -3644,12 +3644,12 @@
                 </a:tc>
                 <a:tc>
                   <a:txBody>
-                    <a:bodyPr/>
+                    <a:bodyPr wrap="square"/>
                     <a:lstStyle/>
                     <a:p>
                       <a:pPr algn="ctr"/>
                       <a:r>
-                        <a:rPr sz="1500" b="1">
+                        <a:rPr sz="1350" b="1">
                           <a:solidFill>
                             <a:srgbClr val="1A2E4A"/>
                           </a:solidFill>
@@ -3658,31 +3658,31 @@
                       </a:r>
                     </a:p>
                   </a:txBody>
-                  <a:tcPr marL="109728" marR="73152" marT="27432" marB="27432">
+                  <a:tcPr marL="91440" marR="54864" marT="18288" marB="18288">
                     <a:solidFill>
                       <a:srgbClr val="E3E5E8"/>
                     </a:solidFill>
                   </a:tcPr>
                 </a:tc>
               </a:tr>
-              <a:tr h="438912">
+              <a:tr h="384048">
                 <a:tc>
                   <a:txBody>
-                    <a:bodyPr/>
+                    <a:bodyPr wrap="square"/>
                     <a:lstStyle/>
                     <a:p>
                       <a:pPr algn="l"/>
                       <a:r>
-                        <a:rPr sz="1500" b="0">
+                        <a:rPr sz="1350" b="0">
                           <a:solidFill>
                             <a:srgbClr val="101214"/>
                           </a:solidFill>
                         </a:rPr>
-                        <a:t>Gradient-boosted trees (quantile loss)</a:t>
+                        <a:t>Gradient-boosted trees (CatBoost, quantile loss q = 0.6, tabular features)</a:t>
                       </a:r>
                     </a:p>
                   </a:txBody>
-                  <a:tcPr marL="109728" marR="73152" marT="27432" marB="27432">
+                  <a:tcPr marL="91440" marR="54864" marT="18288" marB="18288">
                     <a:solidFill>
                       <a:srgbClr val="FFFFFF"/>
                     </a:solidFill>
@@ -3690,12 +3690,12 @@
                 </a:tc>
                 <a:tc>
                   <a:txBody>
-                    <a:bodyPr/>
+                    <a:bodyPr wrap="square"/>
                     <a:lstStyle/>
                     <a:p>
                       <a:pPr algn="ctr"/>
                       <a:r>
-                        <a:rPr sz="1500" b="0">
+                        <a:rPr sz="1350" b="0">
                           <a:solidFill>
                             <a:srgbClr val="101214"/>
                           </a:solidFill>
@@ -3704,7 +3704,7 @@
                       </a:r>
                     </a:p>
                   </a:txBody>
-                  <a:tcPr marL="109728" marR="73152" marT="27432" marB="27432">
+                  <a:tcPr marL="91440" marR="54864" marT="18288" marB="18288">
                     <a:solidFill>
                       <a:srgbClr val="FFFFFF"/>
                     </a:solidFill>
@@ -3712,12 +3712,12 @@
                 </a:tc>
                 <a:tc>
                   <a:txBody>
-                    <a:bodyPr/>
+                    <a:bodyPr wrap="square"/>
                     <a:lstStyle/>
                     <a:p>
                       <a:pPr algn="ctr"/>
                       <a:r>
-                        <a:rPr sz="1500" b="0">
+                        <a:rPr sz="1350" b="0">
                           <a:solidFill>
                             <a:srgbClr val="101214"/>
                           </a:solidFill>
@@ -3726,31 +3726,31 @@
                       </a:r>
                     </a:p>
                   </a:txBody>
-                  <a:tcPr marL="109728" marR="73152" marT="27432" marB="27432">
+                  <a:tcPr marL="91440" marR="54864" marT="18288" marB="18288">
                     <a:solidFill>
                       <a:srgbClr val="FFFFFF"/>
                     </a:solidFill>
                   </a:tcPr>
                 </a:tc>
               </a:tr>
-              <a:tr h="438912">
+              <a:tr h="384048">
                 <a:tc>
                   <a:txBody>
-                    <a:bodyPr/>
+                    <a:bodyPr wrap="square"/>
                     <a:lstStyle/>
                     <a:p>
                       <a:pPr algn="l"/>
                       <a:r>
-                        <a:rPr sz="1500" b="0">
+                        <a:rPr sz="1350" b="0">
                           <a:solidFill>
                             <a:srgbClr val="101214"/>
                           </a:solidFill>
                         </a:rPr>
-                        <a:t>Fingerprint network</a:t>
+                        <a:t>Fully-connected network on molecular fingerprints</a:t>
                       </a:r>
                     </a:p>
                   </a:txBody>
-                  <a:tcPr marL="109728" marR="73152" marT="27432" marB="27432">
+                  <a:tcPr marL="91440" marR="54864" marT="18288" marB="18288">
                     <a:solidFill>
                       <a:srgbClr val="FFFFFF"/>
                     </a:solidFill>
@@ -3758,12 +3758,12 @@
                 </a:tc>
                 <a:tc>
                   <a:txBody>
-                    <a:bodyPr/>
+                    <a:bodyPr wrap="square"/>
                     <a:lstStyle/>
                     <a:p>
                       <a:pPr algn="ctr"/>
                       <a:r>
-                        <a:rPr sz="1500" b="0">
+                        <a:rPr sz="1350" b="0">
                           <a:solidFill>
                             <a:srgbClr val="101214"/>
                           </a:solidFill>
@@ -3772,7 +3772,7 @@
                       </a:r>
                     </a:p>
                   </a:txBody>
-                  <a:tcPr marL="109728" marR="73152" marT="27432" marB="27432">
+                  <a:tcPr marL="91440" marR="54864" marT="18288" marB="18288">
                     <a:solidFill>
                       <a:srgbClr val="FFFFFF"/>
                     </a:solidFill>
@@ -3780,12 +3780,12 @@
                 </a:tc>
                 <a:tc>
                   <a:txBody>
-                    <a:bodyPr/>
+                    <a:bodyPr wrap="square"/>
                     <a:lstStyle/>
                     <a:p>
                       <a:pPr algn="ctr"/>
                       <a:r>
-                        <a:rPr sz="1500" b="0">
+                        <a:rPr sz="1350" b="0">
                           <a:solidFill>
                             <a:srgbClr val="101214"/>
                           </a:solidFill>
@@ -3794,31 +3794,31 @@
                       </a:r>
                     </a:p>
                   </a:txBody>
-                  <a:tcPr marL="109728" marR="73152" marT="27432" marB="27432">
+                  <a:tcPr marL="91440" marR="54864" marT="18288" marB="18288">
                     <a:solidFill>
                       <a:srgbClr val="FFFFFF"/>
                     </a:solidFill>
                   </a:tcPr>
                 </a:tc>
               </a:tr>
-              <a:tr h="438912">
+              <a:tr h="384048">
                 <a:tc>
                   <a:txBody>
-                    <a:bodyPr/>
+                    <a:bodyPr wrap="square"/>
                     <a:lstStyle/>
                     <a:p>
                       <a:pPr algn="l"/>
                       <a:r>
-                        <a:rPr sz="1500" b="0">
+                        <a:rPr sz="1350" b="0">
                           <a:solidFill>
                             <a:srgbClr val="101214"/>
                           </a:solidFill>
                         </a:rPr>
-                        <a:t>3D distance encoder + new contrast weight</a:t>
+                        <a:t>3D distance encoder (GFN2-xTB geometries), pair-contrast loss weight 4</a:t>
                       </a:r>
                     </a:p>
                   </a:txBody>
-                  <a:tcPr marL="109728" marR="73152" marT="27432" marB="27432">
+                  <a:tcPr marL="91440" marR="54864" marT="18288" marB="18288">
                     <a:solidFill>
                       <a:srgbClr val="FFFFFF"/>
                     </a:solidFill>
@@ -3826,12 +3826,12 @@
                 </a:tc>
                 <a:tc>
                   <a:txBody>
-                    <a:bodyPr/>
+                    <a:bodyPr wrap="square"/>
                     <a:lstStyle/>
                     <a:p>
                       <a:pPr algn="ctr"/>
                       <a:r>
-                        <a:rPr sz="1500" b="0">
+                        <a:rPr sz="1350" b="0">
                           <a:solidFill>
                             <a:srgbClr val="101214"/>
                           </a:solidFill>
@@ -3840,7 +3840,7 @@
                       </a:r>
                     </a:p>
                   </a:txBody>
-                  <a:tcPr marL="109728" marR="73152" marT="27432" marB="27432">
+                  <a:tcPr marL="91440" marR="54864" marT="18288" marB="18288">
                     <a:solidFill>
                       <a:srgbClr val="FFFFFF"/>
                     </a:solidFill>
@@ -3848,12 +3848,12 @@
                 </a:tc>
                 <a:tc>
                   <a:txBody>
-                    <a:bodyPr/>
+                    <a:bodyPr wrap="square"/>
                     <a:lstStyle/>
                     <a:p>
                       <a:pPr algn="ctr"/>
                       <a:r>
-                        <a:rPr sz="1500" b="0">
+                        <a:rPr sz="1350" b="0">
                           <a:solidFill>
                             <a:srgbClr val="101214"/>
                           </a:solidFill>
@@ -3862,31 +3862,31 @@
                       </a:r>
                     </a:p>
                   </a:txBody>
-                  <a:tcPr marL="109728" marR="73152" marT="27432" marB="27432">
+                  <a:tcPr marL="91440" marR="54864" marT="18288" marB="18288">
                     <a:solidFill>
                       <a:srgbClr val="FFFFFF"/>
                     </a:solidFill>
                   </a:tcPr>
                 </a:tc>
               </a:tr>
-              <a:tr h="438912">
+              <a:tr h="384048">
                 <a:tc>
                   <a:txBody>
-                    <a:bodyPr/>
+                    <a:bodyPr wrap="square"/>
                     <a:lstStyle/>
                     <a:p>
                       <a:pPr algn="l"/>
                       <a:r>
-                        <a:rPr sz="1500" b="0">
+                        <a:rPr sz="1350" b="0">
                           <a:solidFill>
                             <a:srgbClr val="101214"/>
                           </a:solidFill>
                         </a:rPr>
-                        <a:t>3D simplicial network, July objective</a:t>
+                        <a:t>3D simplicial network (Vietoris–Rips), pair-contrast loss weight 2</a:t>
                       </a:r>
                     </a:p>
                   </a:txBody>
-                  <a:tcPr marL="109728" marR="73152" marT="27432" marB="27432">
+                  <a:tcPr marL="91440" marR="54864" marT="18288" marB="18288">
                     <a:solidFill>
                       <a:srgbClr val="FFFFFF"/>
                     </a:solidFill>
@@ -3894,12 +3894,12 @@
                 </a:tc>
                 <a:tc>
                   <a:txBody>
-                    <a:bodyPr/>
+                    <a:bodyPr wrap="square"/>
                     <a:lstStyle/>
                     <a:p>
                       <a:pPr algn="ctr"/>
                       <a:r>
-                        <a:rPr sz="1500" b="0">
+                        <a:rPr sz="1350" b="0">
                           <a:solidFill>
                             <a:srgbClr val="101214"/>
                           </a:solidFill>
@@ -3908,7 +3908,7 @@
                       </a:r>
                     </a:p>
                   </a:txBody>
-                  <a:tcPr marL="109728" marR="73152" marT="27432" marB="27432">
+                  <a:tcPr marL="91440" marR="54864" marT="18288" marB="18288">
                     <a:solidFill>
                       <a:srgbClr val="FFFFFF"/>
                     </a:solidFill>
@@ -3916,12 +3916,12 @@
                 </a:tc>
                 <a:tc>
                   <a:txBody>
-                    <a:bodyPr/>
+                    <a:bodyPr wrap="square"/>
                     <a:lstStyle/>
                     <a:p>
                       <a:pPr algn="ctr"/>
                       <a:r>
-                        <a:rPr sz="1500" b="0">
+                        <a:rPr sz="1350" b="0">
                           <a:solidFill>
                             <a:srgbClr val="101214"/>
                           </a:solidFill>
@@ -3930,31 +3930,31 @@
                       </a:r>
                     </a:p>
                   </a:txBody>
-                  <a:tcPr marL="109728" marR="73152" marT="27432" marB="27432">
+                  <a:tcPr marL="91440" marR="54864" marT="18288" marB="18288">
                     <a:solidFill>
                       <a:srgbClr val="FFFFFF"/>
                     </a:solidFill>
                   </a:tcPr>
                 </a:tc>
               </a:tr>
-              <a:tr h="438912">
+              <a:tr h="384048">
                 <a:tc>
                   <a:txBody>
-                    <a:bodyPr/>
+                    <a:bodyPr wrap="square"/>
                     <a:lstStyle/>
                     <a:p>
                       <a:pPr algn="l"/>
                       <a:r>
-                        <a:rPr sz="1500" b="0">
+                        <a:rPr sz="1350" b="0">
                           <a:solidFill>
                             <a:srgbClr val="101214"/>
                           </a:solidFill>
                         </a:rPr>
-                        <a:t>3D simplicial network + new contrast weight</a:t>
+                        <a:t>3D simplicial network (Vietoris–Rips), pair-contrast loss weight 4</a:t>
                       </a:r>
                     </a:p>
                   </a:txBody>
-                  <a:tcPr marL="109728" marR="73152" marT="27432" marB="27432">
+                  <a:tcPr marL="91440" marR="54864" marT="18288" marB="18288">
                     <a:solidFill>
                       <a:srgbClr val="FFFFFF"/>
                     </a:solidFill>
@@ -3962,12 +3962,12 @@
                 </a:tc>
                 <a:tc>
                   <a:txBody>
-                    <a:bodyPr/>
+                    <a:bodyPr wrap="square"/>
                     <a:lstStyle/>
                     <a:p>
                       <a:pPr algn="ctr"/>
                       <a:r>
-                        <a:rPr sz="1500" b="0">
+                        <a:rPr sz="1350" b="0">
                           <a:solidFill>
                             <a:srgbClr val="101214"/>
                           </a:solidFill>
@@ -3976,7 +3976,7 @@
                       </a:r>
                     </a:p>
                   </a:txBody>
-                  <a:tcPr marL="109728" marR="73152" marT="27432" marB="27432">
+                  <a:tcPr marL="91440" marR="54864" marT="18288" marB="18288">
                     <a:solidFill>
                       <a:srgbClr val="FFFFFF"/>
                     </a:solidFill>
@@ -3984,12 +3984,12 @@
                 </a:tc>
                 <a:tc>
                   <a:txBody>
-                    <a:bodyPr/>
+                    <a:bodyPr wrap="square"/>
                     <a:lstStyle/>
                     <a:p>
                       <a:pPr algn="ctr"/>
                       <a:r>
-                        <a:rPr sz="1500" b="0">
+                        <a:rPr sz="1350" b="0">
                           <a:solidFill>
                             <a:srgbClr val="101214"/>
                           </a:solidFill>
@@ -3998,44 +3998,55 @@
                       </a:r>
                     </a:p>
                   </a:txBody>
-                  <a:tcPr marL="109728" marR="73152" marT="27432" marB="27432">
+                  <a:tcPr marL="91440" marR="54864" marT="18288" marB="18288">
                     <a:solidFill>
                       <a:srgbClr val="FFFFFF"/>
                     </a:solidFill>
                   </a:tcPr>
                 </a:tc>
               </a:tr>
-              <a:tr h="438912">
+              <a:tr h="621792">
                 <a:tc>
                   <a:txBody>
-                    <a:bodyPr/>
+                    <a:bodyPr wrap="square"/>
                     <a:lstStyle/>
                     <a:p>
                       <a:pPr algn="l"/>
                       <a:r>
-                        <a:rPr sz="1500" b="0">
+                        <a:rPr sz="1350" b="0">
                           <a:solidFill>
                             <a:srgbClr val="101214"/>
                           </a:solidFill>
                         </a:rPr>
-                        <a:t>July 3-model combination (baseline)</a:t>
+                        <a:t>Combination: CatBoost + fingerprint network + simplicial network (weight 2);</a:t>
+                      </a:r>
+                    </a:p>
+                    <a:p>
+                      <a:pPr algn="l"/>
+                      <a:r>
+                        <a:rPr sz="1350" b="0">
+                          <a:solidFill>
+                            <a:srgbClr val="101214"/>
+                          </a:solidFill>
+                        </a:rPr>
+                        <a:t>mixing weights fitted on row-level log D</a:t>
                       </a:r>
                     </a:p>
                   </a:txBody>
-                  <a:tcPr marL="109728" marR="73152" marT="27432" marB="27432">
+                  <a:tcPr marL="91440" marR="54864" marT="18288" marB="18288">
                     <a:solidFill>
-                      <a:srgbClr val="FFFFFF"/>
+                      <a:srgbClr val="F4F6F8"/>
                     </a:solidFill>
                   </a:tcPr>
                 </a:tc>
                 <a:tc>
                   <a:txBody>
-                    <a:bodyPr/>
+                    <a:bodyPr wrap="square"/>
                     <a:lstStyle/>
                     <a:p>
                       <a:pPr algn="ctr"/>
                       <a:r>
-                        <a:rPr sz="1500" b="0">
+                        <a:rPr sz="1350" b="0">
                           <a:solidFill>
                             <a:srgbClr val="101214"/>
                           </a:solidFill>
@@ -4044,20 +4055,20 @@
                       </a:r>
                     </a:p>
                   </a:txBody>
-                  <a:tcPr marL="109728" marR="73152" marT="27432" marB="27432">
+                  <a:tcPr marL="91440" marR="54864" marT="18288" marB="18288">
                     <a:solidFill>
-                      <a:srgbClr val="FFFFFF"/>
+                      <a:srgbClr val="F4F6F8"/>
                     </a:solidFill>
                   </a:tcPr>
                 </a:tc>
                 <a:tc>
                   <a:txBody>
-                    <a:bodyPr/>
+                    <a:bodyPr wrap="square"/>
                     <a:lstStyle/>
                     <a:p>
                       <a:pPr algn="ctr"/>
                       <a:r>
-                        <a:rPr sz="1500" b="0">
+                        <a:rPr sz="1350" b="0">
                           <a:solidFill>
                             <a:srgbClr val="101214"/>
                           </a:solidFill>
@@ -4066,31 +4077,42 @@
                       </a:r>
                     </a:p>
                   </a:txBody>
-                  <a:tcPr marL="109728" marR="73152" marT="27432" marB="27432">
+                  <a:tcPr marL="91440" marR="54864" marT="18288" marB="18288">
                     <a:solidFill>
-                      <a:srgbClr val="FFFFFF"/>
+                      <a:srgbClr val="F4F6F8"/>
                     </a:solidFill>
                   </a:tcPr>
                 </a:tc>
               </a:tr>
-              <a:tr h="438912">
+              <a:tr h="621792">
                 <a:tc>
                   <a:txBody>
-                    <a:bodyPr/>
+                    <a:bodyPr wrap="square"/>
                     <a:lstStyle/>
                     <a:p>
                       <a:pPr algn="l"/>
                       <a:r>
-                        <a:rPr sz="1500" b="1">
+                        <a:rPr sz="1350" b="1">
                           <a:solidFill>
                             <a:srgbClr val="101214"/>
                           </a:solidFill>
                         </a:rPr>
-                        <a:t>Best combination, fitted on pairs directly</a:t>
+                        <a:t>Combination: CatBoost + fingerprint network + distance encoder (weight 4);</a:t>
+                      </a:r>
+                    </a:p>
+                    <a:p>
+                      <a:pPr algn="l"/>
+                      <a:r>
+                        <a:rPr sz="1350" b="1">
+                          <a:solidFill>
+                            <a:srgbClr val="101214"/>
+                          </a:solidFill>
+                        </a:rPr>
+                        <a:t>mixing weights fitted on the 905 adjacent pairs</a:t>
                       </a:r>
                     </a:p>
                   </a:txBody>
-                  <a:tcPr marL="109728" marR="73152" marT="27432" marB="27432">
+                  <a:tcPr marL="91440" marR="54864" marT="18288" marB="18288">
                     <a:solidFill>
                       <a:srgbClr val="F4F6F8"/>
                     </a:solidFill>
@@ -4098,12 +4120,12 @@
                 </a:tc>
                 <a:tc>
                   <a:txBody>
-                    <a:bodyPr/>
+                    <a:bodyPr wrap="square"/>
                     <a:lstStyle/>
                     <a:p>
                       <a:pPr algn="ctr"/>
                       <a:r>
-                        <a:rPr sz="1500" b="1">
+                        <a:rPr sz="1350" b="1">
                           <a:solidFill>
                             <a:srgbClr val="101214"/>
                           </a:solidFill>
@@ -4112,7 +4134,7 @@
                       </a:r>
                     </a:p>
                   </a:txBody>
-                  <a:tcPr marL="109728" marR="73152" marT="27432" marB="27432">
+                  <a:tcPr marL="91440" marR="54864" marT="18288" marB="18288">
                     <a:solidFill>
                       <a:srgbClr val="F4F6F8"/>
                     </a:solidFill>
@@ -4120,12 +4142,12 @@
                 </a:tc>
                 <a:tc>
                   <a:txBody>
-                    <a:bodyPr/>
+                    <a:bodyPr wrap="square"/>
                     <a:lstStyle/>
                     <a:p>
                       <a:pPr algn="ctr"/>
                       <a:r>
-                        <a:rPr sz="1500" b="1">
+                        <a:rPr sz="1350" b="1">
                           <a:solidFill>
                             <a:srgbClr val="101214"/>
                           </a:solidFill>
@@ -4134,22 +4156,22 @@
                       </a:r>
                     </a:p>
                   </a:txBody>
-                  <a:tcPr marL="109728" marR="73152" marT="27432" marB="27432">
+                  <a:tcPr marL="91440" marR="54864" marT="18288" marB="18288">
                     <a:solidFill>
                       <a:srgbClr val="F4F6F8"/>
                     </a:solidFill>
                   </a:tcPr>
                 </a:tc>
               </a:tr>
-              <a:tr h="438912">
+              <a:tr h="384048">
                 <a:tc>
                   <a:txBody>
-                    <a:bodyPr/>
+                    <a:bodyPr wrap="square"/>
                     <a:lstStyle/>
                     <a:p>
                       <a:pPr algn="l"/>
                       <a:r>
-                        <a:rPr sz="1500" b="0">
+                        <a:rPr sz="1350" b="0">
                           <a:solidFill>
                             <a:srgbClr val="101214"/>
                           </a:solidFill>
@@ -4158,7 +4180,7 @@
                       </a:r>
                     </a:p>
                   </a:txBody>
-                  <a:tcPr marL="109728" marR="73152" marT="27432" marB="27432">
+                  <a:tcPr marL="91440" marR="54864" marT="18288" marB="18288">
                     <a:solidFill>
                       <a:srgbClr val="F4F6F8"/>
                     </a:solidFill>
@@ -4166,12 +4188,12 @@
                 </a:tc>
                 <a:tc>
                   <a:txBody>
-                    <a:bodyPr/>
+                    <a:bodyPr wrap="square"/>
                     <a:lstStyle/>
                     <a:p>
                       <a:pPr algn="ctr"/>
                       <a:r>
-                        <a:rPr sz="1500" b="0">
+                        <a:rPr sz="1350" b="0">
                           <a:solidFill>
                             <a:srgbClr val="101214"/>
                           </a:solidFill>
@@ -4180,7 +4202,7 @@
                       </a:r>
                     </a:p>
                   </a:txBody>
-                  <a:tcPr marL="109728" marR="73152" marT="27432" marB="27432">
+                  <a:tcPr marL="91440" marR="54864" marT="18288" marB="18288">
                     <a:solidFill>
                       <a:srgbClr val="F4F6F8"/>
                     </a:solidFill>
@@ -4188,12 +4210,12 @@
                 </a:tc>
                 <a:tc>
                   <a:txBody>
-                    <a:bodyPr/>
+                    <a:bodyPr wrap="square"/>
                     <a:lstStyle/>
                     <a:p>
                       <a:pPr algn="ctr"/>
                       <a:r>
-                        <a:rPr sz="1500" b="0">
+                        <a:rPr sz="1350" b="0">
                           <a:solidFill>
                             <a:srgbClr val="101214"/>
                           </a:solidFill>
@@ -4202,7 +4224,7 @@
                       </a:r>
                     </a:p>
                   </a:txBody>
-                  <a:tcPr marL="109728" marR="73152" marT="27432" marB="27432">
+                  <a:tcPr marL="91440" marR="54864" marT="18288" marB="18288">
                     <a:solidFill>
                       <a:srgbClr val="F4F6F8"/>
                     </a:solidFill>
@@ -4221,7 +4243,7 @@
         </p:nvSpPr>
         <p:spPr>
           <a:xfrm>
-            <a:off x="822960" y="5897880"/>
+            <a:off x="822960" y="5989320"/>
             <a:ext cx="10515600" cy="731520"/>
           </a:xfrm>
           <a:prstGeom prst="rect">
@@ -4241,7 +4263,7 @@
                   <a:srgbClr val="52514E"/>
                 </a:solidFill>
               </a:rPr>
-              <a:t>'July objective' / 'July baseline' = the objective and 3-model stack frozen in the July 2026 internal report (contrast weight 2), before this campaign's loss changes — nothing is published yet. The pair-fitted combination optimises pairs only, so it has no overall score. Ceiling: separations reproduce to ±0.153 on a spread of 0.224 → 1 − (0.153/0.224)² ≈ 0.53.</a:t>
+              <a:t>Each combination is a linear mix of the listed models' out-of-fold predictions. The pair-fitted combination optimises the adjacent pairs only, so it has no overall score. Ceiling: separations reproduce to ±0.153 on a spread of 0.224 → 1 − (0.153/0.224)² ≈ 0.53. Nothing is published yet.</a:t>
             </a:r>
           </a:p>
         </p:txBody>

</xml_diff>